<commit_message>
updating ppt and agenda for class_25
</commit_message>
<xml_diff>
--- a/lectures/in-class_activities/class_25.pptx
+++ b/lectures/in-class_activities/class_25.pptx
@@ -14,9 +14,9 @@
     <p:sldId id="1605" r:id="rId5"/>
     <p:sldId id="1689" r:id="rId6"/>
     <p:sldId id="1587" r:id="rId7"/>
-    <p:sldId id="1811" r:id="rId8"/>
+    <p:sldId id="1814" r:id="rId8"/>
     <p:sldId id="1812" r:id="rId9"/>
-    <p:sldId id="1813" r:id="rId10"/>
+    <p:sldId id="1815" r:id="rId10"/>
     <p:sldId id="1604" r:id="rId11"/>
   </p:sldIdLst>
   <p:sldSz cx="12192000" cy="6858000"/>
@@ -206,7 +206,7 @@
           <a:p>
             <a:fld id="{6AC7DB66-C6D6-B24E-B345-FA3772C924EA}" type="datetimeFigureOut">
               <a:rPr lang="en-US" smtClean="0"/>
-              <a:t>12/6/21</a:t>
+              <a:t>12/1/25</a:t>
             </a:fld>
             <a:endParaRPr lang="en-US"/>
           </a:p>
@@ -1119,13 +1119,15 @@
           <a:p>
             <a:r>
               <a:rPr lang="en-US"/>
-              <a:t>Which parasite species would you predict might have a positive response to conservation? In your answer, please briefly explain why!</a:t>
+              <a:t>Do not modify the notes in this section to avoid tampering with the Poll Everywhere activity.
+More info at polleverywhere.com/support
+Which parasite species would you predict might have a positive response to conservation? In your answer, please briefly explain why!</a:t>
             </a:r>
           </a:p>
           <a:p>
             <a:r>
               <a:rPr lang="en-US"/>
-              <a:t>https://www.polleverywhere.com/discourses/Vlz6V7sBvFjlFJUGJN2jY</a:t>
+              <a:t>https://www.polleverywhere.com/discourses/QLjW2muurzkLDW1FShV0F</a:t>
             </a:r>
           </a:p>
         </p:txBody>
@@ -1156,7 +1158,7 @@
     </p:spTree>
     <p:extLst>
       <p:ext uri="{BB962C8B-B14F-4D97-AF65-F5344CB8AC3E}">
-        <p14:creationId xmlns:p14="http://schemas.microsoft.com/office/powerpoint/2010/main" val="3769814774"/>
+        <p14:creationId xmlns:p14="http://schemas.microsoft.com/office/powerpoint/2010/main" val="1270463303"/>
       </p:ext>
     </p:extLst>
   </p:cSld>
@@ -1296,13 +1298,15 @@
           <a:p>
             <a:r>
               <a:rPr lang="en-US"/>
-              <a:t>Which parasite species would you predict might have a negative response to conservation? In your answer, please briefly explain why!</a:t>
+              <a:t>Do not modify the notes in this section to avoid tampering with the Poll Everywhere activity.
+More info at polleverywhere.com/support
+Which parasite species would you predict might have a negative response to conservation? In your answer, please briefly explain why!</a:t>
             </a:r>
           </a:p>
           <a:p>
             <a:r>
               <a:rPr lang="en-US"/>
-              <a:t>https://www.polleverywhere.com/discourses/D0xlamsHp37G4tIHnZ3fc</a:t>
+              <a:t>https://www.polleverywhere.com/discourses/Yt8obg4G8UOitTw6nL6m7</a:t>
             </a:r>
           </a:p>
         </p:txBody>
@@ -1333,7 +1337,7 @@
     </p:spTree>
     <p:extLst>
       <p:ext uri="{BB962C8B-B14F-4D97-AF65-F5344CB8AC3E}">
-        <p14:creationId xmlns:p14="http://schemas.microsoft.com/office/powerpoint/2010/main" val="3826443455"/>
+        <p14:creationId xmlns:p14="http://schemas.microsoft.com/office/powerpoint/2010/main" val="2443632849"/>
       </p:ext>
     </p:extLst>
   </p:cSld>
@@ -1490,7 +1494,7 @@
           <a:p>
             <a:fld id="{21DDE3A9-9D48-7D40-AF95-520AE186EA5D}" type="datetimeFigureOut">
               <a:rPr lang="en-US" smtClean="0"/>
-              <a:t>12/6/21</a:t>
+              <a:t>12/1/25</a:t>
             </a:fld>
             <a:endParaRPr lang="en-US"/>
           </a:p>
@@ -1688,7 +1692,7 @@
           <a:p>
             <a:fld id="{21DDE3A9-9D48-7D40-AF95-520AE186EA5D}" type="datetimeFigureOut">
               <a:rPr lang="en-US" smtClean="0"/>
-              <a:t>12/6/21</a:t>
+              <a:t>12/1/25</a:t>
             </a:fld>
             <a:endParaRPr lang="en-US"/>
           </a:p>
@@ -1896,7 +1900,7 @@
           <a:p>
             <a:fld id="{21DDE3A9-9D48-7D40-AF95-520AE186EA5D}" type="datetimeFigureOut">
               <a:rPr lang="en-US" smtClean="0"/>
-              <a:t>12/6/21</a:t>
+              <a:t>12/1/25</a:t>
             </a:fld>
             <a:endParaRPr lang="en-US"/>
           </a:p>
@@ -2094,7 +2098,7 @@
           <a:p>
             <a:fld id="{21DDE3A9-9D48-7D40-AF95-520AE186EA5D}" type="datetimeFigureOut">
               <a:rPr lang="en-US" smtClean="0"/>
-              <a:t>12/6/21</a:t>
+              <a:t>12/1/25</a:t>
             </a:fld>
             <a:endParaRPr lang="en-US"/>
           </a:p>
@@ -2369,7 +2373,7 @@
           <a:p>
             <a:fld id="{21DDE3A9-9D48-7D40-AF95-520AE186EA5D}" type="datetimeFigureOut">
               <a:rPr lang="en-US" smtClean="0"/>
-              <a:t>12/6/21</a:t>
+              <a:t>12/1/25</a:t>
             </a:fld>
             <a:endParaRPr lang="en-US"/>
           </a:p>
@@ -2634,7 +2638,7 @@
           <a:p>
             <a:fld id="{21DDE3A9-9D48-7D40-AF95-520AE186EA5D}" type="datetimeFigureOut">
               <a:rPr lang="en-US" smtClean="0"/>
-              <a:t>12/6/21</a:t>
+              <a:t>12/1/25</a:t>
             </a:fld>
             <a:endParaRPr lang="en-US"/>
           </a:p>
@@ -3046,7 +3050,7 @@
           <a:p>
             <a:fld id="{21DDE3A9-9D48-7D40-AF95-520AE186EA5D}" type="datetimeFigureOut">
               <a:rPr lang="en-US" smtClean="0"/>
-              <a:t>12/6/21</a:t>
+              <a:t>12/1/25</a:t>
             </a:fld>
             <a:endParaRPr lang="en-US"/>
           </a:p>
@@ -3187,7 +3191,7 @@
           <a:p>
             <a:fld id="{21DDE3A9-9D48-7D40-AF95-520AE186EA5D}" type="datetimeFigureOut">
               <a:rPr lang="en-US" smtClean="0"/>
-              <a:t>12/6/21</a:t>
+              <a:t>12/1/25</a:t>
             </a:fld>
             <a:endParaRPr lang="en-US"/>
           </a:p>
@@ -3300,7 +3304,7 @@
           <a:p>
             <a:fld id="{21DDE3A9-9D48-7D40-AF95-520AE186EA5D}" type="datetimeFigureOut">
               <a:rPr lang="en-US" smtClean="0"/>
-              <a:t>12/6/21</a:t>
+              <a:t>12/1/25</a:t>
             </a:fld>
             <a:endParaRPr lang="en-US"/>
           </a:p>
@@ -3611,7 +3615,7 @@
           <a:p>
             <a:fld id="{21DDE3A9-9D48-7D40-AF95-520AE186EA5D}" type="datetimeFigureOut">
               <a:rPr lang="en-US" smtClean="0"/>
-              <a:t>12/6/21</a:t>
+              <a:t>12/1/25</a:t>
             </a:fld>
             <a:endParaRPr lang="en-US"/>
           </a:p>
@@ -3899,7 +3903,7 @@
           <a:p>
             <a:fld id="{21DDE3A9-9D48-7D40-AF95-520AE186EA5D}" type="datetimeFigureOut">
               <a:rPr lang="en-US" smtClean="0"/>
-              <a:t>12/6/21</a:t>
+              <a:t>12/1/25</a:t>
             </a:fld>
             <a:endParaRPr lang="en-US"/>
           </a:p>
@@ -4140,7 +4144,7 @@
           <a:p>
             <a:fld id="{21DDE3A9-9D48-7D40-AF95-520AE186EA5D}" type="datetimeFigureOut">
               <a:rPr lang="en-US" smtClean="0"/>
-              <a:t>12/6/21</a:t>
+              <a:t>12/1/25</a:t>
             </a:fld>
             <a:endParaRPr lang="en-US"/>
           </a:p>
@@ -4609,7 +4613,7 @@
                 <a:latin typeface="Avenir Book" panose="02000503020000020003" pitchFamily="2" charset="0"/>
                 <a:cs typeface="Avenir"/>
               </a:rPr>
-              <a:t>Practical session 25</a:t>
+              <a:t>Class 25</a:t>
             </a:r>
             <a:r>
               <a:rPr lang="en-US" sz="4800" dirty="0">
@@ -4725,7 +4729,7 @@
                 <a:latin typeface="Avenir Book" panose="02000503020000020003" pitchFamily="2" charset="0"/>
                 <a:cs typeface="Avenir"/>
               </a:rPr>
-              <a:t>Practical session 25</a:t>
+              <a:t>Class 25</a:t>
             </a:r>
             <a:r>
               <a:rPr lang="en-US" sz="4800" dirty="0">
@@ -6471,7 +6475,7 @@
           <p:cNvPr id="2" name="Title 1">
             <a:extLst>
               <a:ext uri="{FF2B5EF4-FFF2-40B4-BE49-F238E27FC236}">
-                <a16:creationId xmlns:a16="http://schemas.microsoft.com/office/drawing/2014/main" id="{C9E8F243-CEE6-4F40-B058-B978C8AB2D1D}"/>
+                <a16:creationId xmlns:a16="http://schemas.microsoft.com/office/drawing/2014/main" id="{12940699-67FA-F600-9786-064910DE0AED}"/>
               </a:ext>
             </a:extLst>
           </p:cNvPr>
@@ -6496,7 +6500,7 @@
           <p:cNvPr id="3" name="Subtitle 2">
             <a:extLst>
               <a:ext uri="{FF2B5EF4-FFF2-40B4-BE49-F238E27FC236}">
-                <a16:creationId xmlns:a16="http://schemas.microsoft.com/office/drawing/2014/main" id="{8B033354-AFE6-3149-B596-E4C5B61A308A}"/>
+                <a16:creationId xmlns:a16="http://schemas.microsoft.com/office/drawing/2014/main" id="{6A6E878D-8EBE-D2B4-EB56-88E5029777F4}"/>
               </a:ext>
             </a:extLst>
           </p:cNvPr>
@@ -6518,10 +6522,10 @@
       </p:sp>
       <p:pic>
         <p:nvPicPr>
-          <p:cNvPr id="5" name="slide.url=https://www.polleverywhere.com/discourses/Vlz6V7sBvFjlFJUGJN2jY">
-            <a:extLst>
-              <a:ext uri="{FF2B5EF4-FFF2-40B4-BE49-F238E27FC236}">
-                <a16:creationId xmlns:a16="http://schemas.microsoft.com/office/drawing/2014/main" id="{3270F22C-C887-3142-B7BD-F546A8D677D5}"/>
+          <p:cNvPr id="5" name="slide.url=https://www.polleverywhere.com/discourses/QLjW2muurzkLDW1FShV0F">
+            <a:extLst>
+              <a:ext uri="{FF2B5EF4-FFF2-40B4-BE49-F238E27FC236}">
+                <a16:creationId xmlns:a16="http://schemas.microsoft.com/office/drawing/2014/main" id="{50D19D35-EF9A-99A9-ECD4-0E990115E259}"/>
               </a:ext>
             </a:extLst>
           </p:cNvPr>
@@ -6549,7 +6553,7 @@
     </p:spTree>
     <p:extLst>
       <p:ext uri="{BB962C8B-B14F-4D97-AF65-F5344CB8AC3E}">
-        <p14:creationId xmlns:p14="http://schemas.microsoft.com/office/powerpoint/2010/main" val="2304134267"/>
+        <p14:creationId xmlns:p14="http://schemas.microsoft.com/office/powerpoint/2010/main" val="2232827124"/>
       </p:ext>
     </p:extLst>
   </p:cSld>
@@ -6741,7 +6745,7 @@
           <p:cNvPr id="2" name="Title 1">
             <a:extLst>
               <a:ext uri="{FF2B5EF4-FFF2-40B4-BE49-F238E27FC236}">
-                <a16:creationId xmlns:a16="http://schemas.microsoft.com/office/drawing/2014/main" id="{01C56EE1-AE51-3D41-AE65-5DBFB8995698}"/>
+                <a16:creationId xmlns:a16="http://schemas.microsoft.com/office/drawing/2014/main" id="{87B48BBB-79F9-8954-5103-0A88EBDF912B}"/>
               </a:ext>
             </a:extLst>
           </p:cNvPr>
@@ -6766,7 +6770,7 @@
           <p:cNvPr id="3" name="Subtitle 2">
             <a:extLst>
               <a:ext uri="{FF2B5EF4-FFF2-40B4-BE49-F238E27FC236}">
-                <a16:creationId xmlns:a16="http://schemas.microsoft.com/office/drawing/2014/main" id="{35FCA820-80CC-6648-BDF9-8B58BB360C41}"/>
+                <a16:creationId xmlns:a16="http://schemas.microsoft.com/office/drawing/2014/main" id="{E1D6438B-AAF4-94A5-FB0F-5E441D4666F9}"/>
               </a:ext>
             </a:extLst>
           </p:cNvPr>
@@ -6788,10 +6792,10 @@
       </p:sp>
       <p:pic>
         <p:nvPicPr>
-          <p:cNvPr id="5" name="slide.url=https://www.polleverywhere.com/discourses/D0xlamsHp37G4tIHnZ3fc">
-            <a:extLst>
-              <a:ext uri="{FF2B5EF4-FFF2-40B4-BE49-F238E27FC236}">
-                <a16:creationId xmlns:a16="http://schemas.microsoft.com/office/drawing/2014/main" id="{DCF6C9A6-2497-9C4B-A349-EB363693510D}"/>
+          <p:cNvPr id="5" name="slide.url=https://www.polleverywhere.com/discourses/Yt8obg4G8UOitTw6nL6m7">
+            <a:extLst>
+              <a:ext uri="{FF2B5EF4-FFF2-40B4-BE49-F238E27FC236}">
+                <a16:creationId xmlns:a16="http://schemas.microsoft.com/office/drawing/2014/main" id="{9101522A-D53D-C50B-983A-B254588EFF14}"/>
               </a:ext>
             </a:extLst>
           </p:cNvPr>
@@ -6819,7 +6823,7 @@
     </p:spTree>
     <p:extLst>
       <p:ext uri="{BB962C8B-B14F-4D97-AF65-F5344CB8AC3E}">
-        <p14:creationId xmlns:p14="http://schemas.microsoft.com/office/powerpoint/2010/main" val="3920586200"/>
+        <p14:creationId xmlns:p14="http://schemas.microsoft.com/office/powerpoint/2010/main" val="3261897721"/>
       </p:ext>
     </p:extLst>
   </p:cSld>

</xml_diff>